<commit_message>
feat(strategy,pptx,dashboard): FDP 생태계 확산·락인 실행전략 3종 + 제품 축 ④ 1장 (v2.46.7)
- 원문 소스 보존 + wiki §4.5: 워크로드 교환 협업(하이퍼스케일러·Pure·VAST·DDN),
  최적화 역량 전문가 5종 분석, FDE 채용·양성·운영안(Palantir 모델 준용)
- PPT 제품 축 ④: SCA→FDP→FDE 락인 플라이휠 + 실행전략 3카드,
  단독 1장본 -fdp-eco 신설, -fdp 4장, 통합본 확장
- 다운로드 카드 5종으로 확장, version v2.46.7 (패치)

Co-Authored-By: Claude Fable 5 <noreply@anthropic.com>
Claude-Session: https://claude.ai/code/session_01P75FajBNDiW5p24ay2HU9V
</commit_message>
<xml_diff>
--- a/dashboard/public/downloads/dev-transformation-summary-fdp.pptx
+++ b/dashboard/public/downloads/dev-transformation-summary-fdp.pptx
@@ -8,9 +8,10 @@
     <p:sldId id="256" r:id="rId2"/>
     <p:sldId id="257" r:id="rId3"/>
     <p:sldId id="258" r:id="rId4"/>
+    <p:sldId id="259" r:id="rId5"/>
   </p:sldIdLst>
   <p:notesMasterIdLst>
-    <p:notesMasterId r:id="rId5"/>
+    <p:notesMasterId r:id="rId6"/>
   </p:notesMasterIdLst>
   <p:sldSz cx="12192000" cy="6858000"/>
   <p:notesSz cx="6858000" cy="12192000"/>
@@ -722,6 +723,94 @@
 </p:notes>
 </file>
 
+<file path=ppt/notesSlides/notesSlide4.xml><?xml version="1.0" encoding="utf-8"?>
+<p:notes xmlns:a="http://schemas.openxmlformats.org/drawingml/2006/main" xmlns:r="http://schemas.openxmlformats.org/officeDocument/2006/relationships" xmlns:p="http://schemas.openxmlformats.org/presentationml/2006/main">
+  <p:cSld>
+    <p:spTree>
+      <p:nvGrpSpPr>
+        <p:cNvPr id="1" name=""/>
+        <p:cNvGrpSpPr/>
+        <p:nvPr/>
+      </p:nvGrpSpPr>
+      <p:grpSpPr>
+        <a:xfrm>
+          <a:off x="0" y="0"/>
+          <a:ext cx="0" cy="0"/>
+          <a:chOff x="0" y="0"/>
+          <a:chExt cx="0" cy="0"/>
+        </a:xfrm>
+      </p:grpSpPr>
+      <p:sp>
+        <p:nvSpPr>
+          <p:cNvPr id="2" name="Slide Image Placeholder 1"/>
+          <p:cNvSpPr>
+            <a:spLocks noGrp="1" noRot="1" noChangeAspect="1"/>
+          </p:cNvSpPr>
+          <p:nvPr>
+            <p:ph type="sldImg"/>
+          </p:nvPr>
+        </p:nvSpPr>
+        <p:spPr/>
+      </p:sp>
+      <p:sp>
+        <p:nvSpPr>
+          <p:cNvPr id="3" name="Notes Placeholder 2"/>
+          <p:cNvSpPr>
+            <a:spLocks noGrp="1"/>
+          </p:cNvSpPr>
+          <p:nvPr>
+            <p:ph type="body" idx="1"/>
+          </p:nvPr>
+        </p:nvSpPr>
+        <p:spPr/>
+        <p:txBody>
+          <a:bodyPr/>
+          <a:lstStyle/>
+          <a:p>
+            <a:r>
+              <a:rPr lang="en-US" dirty="0"/>
+              <a:t/>
+            </a:r>
+            <a:endParaRPr lang="en-US" dirty="0"/>
+          </a:p>
+        </p:txBody>
+      </p:sp>
+      <p:sp>
+        <p:nvSpPr>
+          <p:cNvPr id="4" name="Slide Number Placeholder 3"/>
+          <p:cNvSpPr>
+            <a:spLocks noGrp="1"/>
+          </p:cNvSpPr>
+          <p:nvPr>
+            <p:ph type="sldNum" sz="quarter" idx="10"/>
+          </p:nvPr>
+        </p:nvSpPr>
+        <p:spPr/>
+        <p:txBody>
+          <a:bodyPr/>
+          <a:lstStyle/>
+          <a:p>
+            <a:fld id="{F7021451-1387-4CA6-816F-3879F97B5CBC}" type="slidenum">
+              <a:rPr lang="en-US"/>
+              <a:t>4</a:t>
+            </a:fld>
+            <a:endParaRPr lang="en-US"/>
+          </a:p>
+        </p:txBody>
+      </p:sp>
+    </p:spTree>
+    <p:extLst>
+      <p:ext uri="{BB962C8B-B14F-4D97-AF65-F5344CB8AC3E}">
+        <p14:creationId xmlns:p14="http://schemas.microsoft.com/office/powerpoint/2010/main" val="1024086991"/>
+      </p:ext>
+    </p:extLst>
+  </p:cSld>
+  <p:clrMapOvr>
+    <a:masterClrMapping/>
+  </p:clrMapOvr>
+</p:notes>
+</file>
+
 <file path=ppt/slideLayouts/slideLayout1.xml><?xml version="1.0" encoding="utf-8"?>
 <p:sldLayout xmlns:a="http://schemas.openxmlformats.org/drawingml/2006/main" xmlns:r="http://schemas.openxmlformats.org/officeDocument/2006/relationships" xmlns:p="http://schemas.openxmlformats.org/presentationml/2006/main" preserve="1">
   <p:cSld name="DEFAULT">
@@ -5594,6 +5683,1340 @@
               <a:t>실행 주체: 인재 축(FDE 스타)이 이 플랫폼을 들고 고객 아키텍처 안으로 들어간다 — 단계: 기본 도구 → 전략 고객 공동검증 → 상용 플랫폼화 → Host Control 확장</a:t>
             </a:r>
             <a:endParaRPr lang="en-US" sz="1350" dirty="0"/>
+          </a:p>
+        </p:txBody>
+      </p:sp>
+    </p:spTree>
+  </p:cSld>
+  <p:clrMapOvr>
+    <a:masterClrMapping/>
+  </p:clrMapOvr>
+</p:sld>
+</file>
+
+<file path=ppt/slides/slide4.xml><?xml version="1.0" encoding="utf-8"?>
+<p:sld xmlns:a="http://schemas.openxmlformats.org/drawingml/2006/main" xmlns:r="http://schemas.openxmlformats.org/officeDocument/2006/relationships" xmlns:p="http://schemas.openxmlformats.org/presentationml/2006/main">
+  <p:cSld name="Slide 4">
+    <p:spTree>
+      <p:nvGrpSpPr>
+        <p:cNvPr id="1" name=""/>
+        <p:cNvGrpSpPr/>
+        <p:nvPr/>
+      </p:nvGrpSpPr>
+      <p:grpSpPr>
+        <a:xfrm>
+          <a:off x="0" y="0"/>
+          <a:ext cx="0" cy="0"/>
+          <a:chOff x="0" y="0"/>
+          <a:chExt cx="0" cy="0"/>
+        </a:xfrm>
+      </p:grpSpPr>
+      <p:sp>
+        <p:nvSpPr>
+          <p:cNvPr id="2" name="Text 0"/>
+          <p:cNvSpPr/>
+          <p:nvPr/>
+        </p:nvSpPr>
+        <p:spPr>
+          <a:xfrm>
+            <a:off x="457200" y="237744"/>
+            <a:ext cx="9765792" cy="566928"/>
+          </a:xfrm>
+          <a:prstGeom prst="rect">
+            <a:avLst/>
+          </a:prstGeom>
+          <a:noFill/>
+          <a:ln/>
+        </p:spPr>
+        <p:txBody>
+          <a:bodyPr wrap="square" lIns="0" tIns="0" rIns="0" bIns="0" rtlCol="0" anchor="ctr"/>
+          <a:lstStyle/>
+          <a:p>
+            <a:pPr indent="0" marL="0">
+              <a:buNone/>
+            </a:pPr>
+            <a:r>
+              <a:rPr lang="en-US" sz="3200" b="1" dirty="0">
+                <a:solidFill>
+                  <a:srgbClr val="17313B"/>
+                </a:solidFill>
+                <a:latin typeface="Malgun Gothic" pitchFamily="34" charset="0"/>
+                <a:ea typeface="Malgun Gothic" pitchFamily="34" charset="-122"/>
+                <a:cs typeface="Malgun Gothic" pitchFamily="34" charset="-120"/>
+              </a:rPr>
+              <a:t>제품·기술 축 — FDP Host–SSD 통합 플랫폼</a:t>
+            </a:r>
+            <a:endParaRPr lang="en-US" sz="3200" dirty="0"/>
+          </a:p>
+        </p:txBody>
+      </p:sp>
+      <p:sp>
+        <p:nvSpPr>
+          <p:cNvPr id="3" name="Text 1"/>
+          <p:cNvSpPr/>
+          <p:nvPr/>
+        </p:nvSpPr>
+        <p:spPr>
+          <a:xfrm>
+            <a:off x="10268712" y="310896"/>
+            <a:ext cx="1463040" cy="420624"/>
+          </a:xfrm>
+          <a:prstGeom prst="roundRect">
+            <a:avLst>
+              <a:gd name="adj" fmla="val 21739"/>
+            </a:avLst>
+          </a:prstGeom>
+          <a:solidFill>
+            <a:srgbClr val="EFF3F5"/>
+          </a:solidFill>
+          <a:ln/>
+        </p:spPr>
+        <p:txBody>
+          <a:bodyPr wrap="square" lIns="0" tIns="0" rIns="0" bIns="0" rtlCol="0" anchor="ctr"/>
+          <a:lstStyle/>
+          <a:p>
+            <a:pPr algn="ctr" indent="0" marL="0">
+              <a:buNone/>
+            </a:pPr>
+            <a:r>
+              <a:rPr lang="en-US" sz="1400" b="1" dirty="0">
+                <a:solidFill>
+                  <a:srgbClr val="5A7184"/>
+                </a:solidFill>
+                <a:latin typeface="Malgun Gothic" pitchFamily="34" charset="0"/>
+                <a:ea typeface="Malgun Gothic" pitchFamily="34" charset="-122"/>
+                <a:cs typeface="Malgun Gothic" pitchFamily="34" charset="-120"/>
+              </a:rPr>
+              <a:t>제품 축 ④</a:t>
+            </a:r>
+            <a:endParaRPr lang="en-US" sz="1400" dirty="0"/>
+          </a:p>
+        </p:txBody>
+      </p:sp>
+      <p:sp>
+        <p:nvSpPr>
+          <p:cNvPr id="4" name="Text 2"/>
+          <p:cNvSpPr/>
+          <p:nvPr/>
+        </p:nvSpPr>
+        <p:spPr>
+          <a:xfrm>
+            <a:off x="457200" y="6510528"/>
+            <a:ext cx="6949440" cy="256032"/>
+          </a:xfrm>
+          <a:prstGeom prst="rect">
+            <a:avLst/>
+          </a:prstGeom>
+          <a:noFill/>
+          <a:ln/>
+        </p:spPr>
+        <p:txBody>
+          <a:bodyPr wrap="square" lIns="0" tIns="0" rIns="0" bIns="0" rtlCol="0" anchor="ctr"/>
+          <a:lstStyle/>
+          <a:p>
+            <a:pPr indent="0" marL="0">
+              <a:buNone/>
+            </a:pPr>
+            <a:r>
+              <a:rPr lang="en-US" sz="1000" dirty="0">
+                <a:solidFill>
+                  <a:srgbClr val="5A7184"/>
+                </a:solidFill>
+                <a:latin typeface="Malgun Gothic" pitchFamily="34" charset="0"/>
+                <a:ea typeface="Malgun Gothic" pitchFamily="34" charset="-122"/>
+                <a:cs typeface="Malgun Gothic" pitchFamily="34" charset="-120"/>
+              </a:rPr>
+              <a:t>삼성전자 메모리사업부 · 개발실 체질 전환 전략 요약 · 2026-07-24</a:t>
+            </a:r>
+            <a:endParaRPr lang="en-US" sz="1000" dirty="0"/>
+          </a:p>
+        </p:txBody>
+      </p:sp>
+      <p:sp>
+        <p:nvSpPr>
+          <p:cNvPr id="5" name="Text 3"/>
+          <p:cNvSpPr/>
+          <p:nvPr/>
+        </p:nvSpPr>
+        <p:spPr>
+          <a:xfrm>
+            <a:off x="7589520" y="6510528"/>
+            <a:ext cx="4142232" cy="256032"/>
+          </a:xfrm>
+          <a:prstGeom prst="rect">
+            <a:avLst/>
+          </a:prstGeom>
+          <a:noFill/>
+          <a:ln/>
+        </p:spPr>
+        <p:txBody>
+          <a:bodyPr wrap="square" lIns="0" tIns="0" rIns="0" bIns="0" rtlCol="0" anchor="ctr"/>
+          <a:lstStyle/>
+          <a:p>
+            <a:pPr algn="r" indent="0" marL="0">
+              <a:buNone/>
+            </a:pPr>
+            <a:r>
+              <a:rPr lang="en-US" sz="1000" dirty="0">
+                <a:solidFill>
+                  <a:srgbClr val="5A7184"/>
+                </a:solidFill>
+                <a:latin typeface="Malgun Gothic" pitchFamily="34" charset="0"/>
+                <a:ea typeface="Malgun Gothic" pitchFamily="34" charset="-122"/>
+                <a:cs typeface="Malgun Gothic" pitchFamily="34" charset="-120"/>
+              </a:rPr>
+              <a:t>원천: wiki/strategies/fdp-host-ssd-platform.md</a:t>
+            </a:r>
+            <a:endParaRPr lang="en-US" sz="1000" dirty="0"/>
+          </a:p>
+        </p:txBody>
+      </p:sp>
+      <p:sp>
+        <p:nvSpPr>
+          <p:cNvPr id="6" name="Text 4"/>
+          <p:cNvSpPr/>
+          <p:nvPr/>
+        </p:nvSpPr>
+        <p:spPr>
+          <a:xfrm>
+            <a:off x="457200" y="822960"/>
+            <a:ext cx="11274552" cy="274320"/>
+          </a:xfrm>
+          <a:prstGeom prst="rect">
+            <a:avLst/>
+          </a:prstGeom>
+          <a:noFill/>
+          <a:ln/>
+        </p:spPr>
+        <p:txBody>
+          <a:bodyPr wrap="square" lIns="0" tIns="0" rIns="0" bIns="0" rtlCol="0" anchor="ctr"/>
+          <a:lstStyle/>
+          <a:p>
+            <a:pPr indent="0" marL="0">
+              <a:buNone/>
+            </a:pPr>
+            <a:r>
+              <a:rPr lang="en-US" sz="1300" b="1" dirty="0">
+                <a:solidFill>
+                  <a:srgbClr val="028090"/>
+                </a:solidFill>
+                <a:latin typeface="Malgun Gothic" pitchFamily="34" charset="0"/>
+                <a:ea typeface="Malgun Gothic" pitchFamily="34" charset="-122"/>
+                <a:cs typeface="Malgun Gothic" pitchFamily="34" charset="-120"/>
+              </a:rPr>
+              <a:t>실행전략  </a:t>
+            </a:r>
+            <a:pPr indent="0" marL="0">
+              <a:buNone/>
+            </a:pPr>
+            <a:r>
+              <a:rPr lang="en-US" sz="1300" i="1" dirty="0">
+                <a:solidFill>
+                  <a:srgbClr val="5A7184"/>
+                </a:solidFill>
+                <a:latin typeface="Malgun Gothic" pitchFamily="34" charset="0"/>
+                <a:ea typeface="Malgun Gothic" pitchFamily="34" charset="-122"/>
+                <a:cs typeface="Malgun Gothic" pitchFamily="34" charset="-120"/>
+              </a:rPr>
+              <a:t>SCA로 다가가고 · FDP로 제공하고 · FDE로 협업한다: 워크로드가 들어올수록 전환비용이 커지는 락인 플라이휠</a:t>
+            </a:r>
+            <a:endParaRPr lang="en-US" sz="1300" dirty="0"/>
+          </a:p>
+        </p:txBody>
+      </p:sp>
+      <p:sp>
+        <p:nvSpPr>
+          <p:cNvPr id="7" name="Text 5"/>
+          <p:cNvSpPr/>
+          <p:nvPr/>
+        </p:nvSpPr>
+        <p:spPr>
+          <a:xfrm>
+            <a:off x="1755648" y="1298448"/>
+            <a:ext cx="1024128" cy="1024128"/>
+          </a:xfrm>
+          <a:prstGeom prst="ellipse">
+            <a:avLst/>
+          </a:prstGeom>
+          <a:solidFill>
+            <a:srgbClr val="5A7184"/>
+          </a:solidFill>
+          <a:ln/>
+        </p:spPr>
+        <p:txBody>
+          <a:bodyPr wrap="square" lIns="0" tIns="0" rIns="0" bIns="0" rtlCol="0" anchor="ctr"/>
+          <a:lstStyle/>
+          <a:p>
+            <a:pPr algn="ctr" indent="0" marL="0">
+              <a:lnSpc>
+                <a:spcPct val="100000"/>
+              </a:lnSpc>
+              <a:buNone/>
+            </a:pPr>
+            <a:r>
+              <a:rPr lang="en-US" sz="1600" b="1" dirty="0">
+                <a:solidFill>
+                  <a:srgbClr val="FFFFFF"/>
+                </a:solidFill>
+                <a:latin typeface="Malgun Gothic" pitchFamily="34" charset="0"/>
+                <a:ea typeface="Malgun Gothic" pitchFamily="34" charset="-122"/>
+                <a:cs typeface="Malgun Gothic" pitchFamily="34" charset="-120"/>
+              </a:rPr>
+              <a:t>SCA</a:t>
+            </a:r>
+            <a:endParaRPr lang="en-US" sz="1600" dirty="0"/>
+          </a:p>
+          <a:p>
+            <a:pPr algn="ctr" indent="0" marL="0">
+              <a:lnSpc>
+                <a:spcPct val="100000"/>
+              </a:lnSpc>
+              <a:buNone/>
+            </a:pPr>
+            <a:r>
+              <a:rPr lang="en-US" sz="1050" dirty="0">
+                <a:solidFill>
+                  <a:srgbClr val="FFFFFF"/>
+                </a:solidFill>
+                <a:latin typeface="Malgun Gothic" pitchFamily="34" charset="0"/>
+                <a:ea typeface="Malgun Gothic" pitchFamily="34" charset="-122"/>
+                <a:cs typeface="Malgun Gothic" pitchFamily="34" charset="-120"/>
+              </a:rPr>
+              <a:t>다가간다</a:t>
+            </a:r>
+            <a:endParaRPr lang="en-US" sz="1600" dirty="0"/>
+          </a:p>
+        </p:txBody>
+      </p:sp>
+      <p:sp>
+        <p:nvSpPr>
+          <p:cNvPr id="8" name="Text 6"/>
+          <p:cNvSpPr/>
+          <p:nvPr/>
+        </p:nvSpPr>
+        <p:spPr>
+          <a:xfrm>
+            <a:off x="658368" y="3346704"/>
+            <a:ext cx="1024128" cy="1024128"/>
+          </a:xfrm>
+          <a:prstGeom prst="ellipse">
+            <a:avLst/>
+          </a:prstGeom>
+          <a:solidFill>
+            <a:srgbClr val="028090"/>
+          </a:solidFill>
+          <a:ln/>
+        </p:spPr>
+        <p:txBody>
+          <a:bodyPr wrap="square" lIns="0" tIns="0" rIns="0" bIns="0" rtlCol="0" anchor="ctr"/>
+          <a:lstStyle/>
+          <a:p>
+            <a:pPr algn="ctr" indent="0" marL="0">
+              <a:lnSpc>
+                <a:spcPct val="100000"/>
+              </a:lnSpc>
+              <a:buNone/>
+            </a:pPr>
+            <a:r>
+              <a:rPr lang="en-US" sz="1600" b="1" dirty="0">
+                <a:solidFill>
+                  <a:srgbClr val="FFFFFF"/>
+                </a:solidFill>
+                <a:latin typeface="Malgun Gothic" pitchFamily="34" charset="0"/>
+                <a:ea typeface="Malgun Gothic" pitchFamily="34" charset="-122"/>
+                <a:cs typeface="Malgun Gothic" pitchFamily="34" charset="-120"/>
+              </a:rPr>
+              <a:t>FDP</a:t>
+            </a:r>
+            <a:endParaRPr lang="en-US" sz="1600" dirty="0"/>
+          </a:p>
+          <a:p>
+            <a:pPr algn="ctr" indent="0" marL="0">
+              <a:lnSpc>
+                <a:spcPct val="100000"/>
+              </a:lnSpc>
+              <a:buNone/>
+            </a:pPr>
+            <a:r>
+              <a:rPr lang="en-US" sz="1050" dirty="0">
+                <a:solidFill>
+                  <a:srgbClr val="FFFFFF"/>
+                </a:solidFill>
+                <a:latin typeface="Malgun Gothic" pitchFamily="34" charset="0"/>
+                <a:ea typeface="Malgun Gothic" pitchFamily="34" charset="-122"/>
+                <a:cs typeface="Malgun Gothic" pitchFamily="34" charset="-120"/>
+              </a:rPr>
+              <a:t>제공한다</a:t>
+            </a:r>
+            <a:endParaRPr lang="en-US" sz="1600" dirty="0"/>
+          </a:p>
+        </p:txBody>
+      </p:sp>
+      <p:sp>
+        <p:nvSpPr>
+          <p:cNvPr id="9" name="Text 7"/>
+          <p:cNvSpPr/>
+          <p:nvPr/>
+        </p:nvSpPr>
+        <p:spPr>
+          <a:xfrm>
+            <a:off x="2852928" y="3346704"/>
+            <a:ext cx="1024128" cy="1024128"/>
+          </a:xfrm>
+          <a:prstGeom prst="ellipse">
+            <a:avLst/>
+          </a:prstGeom>
+          <a:solidFill>
+            <a:srgbClr val="02A878"/>
+          </a:solidFill>
+          <a:ln/>
+        </p:spPr>
+        <p:txBody>
+          <a:bodyPr wrap="square" lIns="0" tIns="0" rIns="0" bIns="0" rtlCol="0" anchor="ctr"/>
+          <a:lstStyle/>
+          <a:p>
+            <a:pPr algn="ctr" indent="0" marL="0">
+              <a:lnSpc>
+                <a:spcPct val="100000"/>
+              </a:lnSpc>
+              <a:buNone/>
+            </a:pPr>
+            <a:r>
+              <a:rPr lang="en-US" sz="1600" b="1" dirty="0">
+                <a:solidFill>
+                  <a:srgbClr val="FFFFFF"/>
+                </a:solidFill>
+                <a:latin typeface="Malgun Gothic" pitchFamily="34" charset="0"/>
+                <a:ea typeface="Malgun Gothic" pitchFamily="34" charset="-122"/>
+                <a:cs typeface="Malgun Gothic" pitchFamily="34" charset="-120"/>
+              </a:rPr>
+              <a:t>FDE</a:t>
+            </a:r>
+            <a:endParaRPr lang="en-US" sz="1600" dirty="0"/>
+          </a:p>
+          <a:p>
+            <a:pPr algn="ctr" indent="0" marL="0">
+              <a:lnSpc>
+                <a:spcPct val="100000"/>
+              </a:lnSpc>
+              <a:buNone/>
+            </a:pPr>
+            <a:r>
+              <a:rPr lang="en-US" sz="1050" dirty="0">
+                <a:solidFill>
+                  <a:srgbClr val="FFFFFF"/>
+                </a:solidFill>
+                <a:latin typeface="Malgun Gothic" pitchFamily="34" charset="0"/>
+                <a:ea typeface="Malgun Gothic" pitchFamily="34" charset="-122"/>
+                <a:cs typeface="Malgun Gothic" pitchFamily="34" charset="-120"/>
+              </a:rPr>
+              <a:t>협업한다</a:t>
+            </a:r>
+            <a:endParaRPr lang="en-US" sz="1600" dirty="0"/>
+          </a:p>
+        </p:txBody>
+      </p:sp>
+      <p:sp>
+        <p:nvSpPr>
+          <p:cNvPr id="10" name="Shape 8"/>
+          <p:cNvSpPr/>
+          <p:nvPr/>
+        </p:nvSpPr>
+        <p:spPr>
+          <a:xfrm flipH="1">
+            <a:off x="1170432" y="2304288"/>
+            <a:ext cx="402336" cy="1005840"/>
+          </a:xfrm>
+          <a:prstGeom prst="line">
+            <a:avLst/>
+          </a:prstGeom>
+          <a:noFill/>
+          <a:ln w="25400">
+            <a:solidFill>
+              <a:srgbClr val="C4CFD6"/>
+            </a:solidFill>
+            <a:prstDash val="solid"/>
+            <a:tailEnd type="triangle"/>
+          </a:ln>
+        </p:spPr>
+      </p:sp>
+      <p:sp>
+        <p:nvSpPr>
+          <p:cNvPr id="11" name="Shape 9"/>
+          <p:cNvSpPr/>
+          <p:nvPr/>
+        </p:nvSpPr>
+        <p:spPr>
+          <a:xfrm>
+            <a:off x="1773936" y="3858768"/>
+            <a:ext cx="987552" cy="914"/>
+          </a:xfrm>
+          <a:prstGeom prst="line">
+            <a:avLst/>
+          </a:prstGeom>
+          <a:noFill/>
+          <a:ln w="25400">
+            <a:solidFill>
+              <a:srgbClr val="C4CFD6"/>
+            </a:solidFill>
+            <a:prstDash val="solid"/>
+            <a:tailEnd type="triangle"/>
+          </a:ln>
+        </p:spPr>
+      </p:sp>
+      <p:sp>
+        <p:nvSpPr>
+          <p:cNvPr id="12" name="Shape 10"/>
+          <p:cNvSpPr/>
+          <p:nvPr/>
+        </p:nvSpPr>
+        <p:spPr>
+          <a:xfrm flipH="1" flipV="1">
+            <a:off x="2907792" y="2286000"/>
+            <a:ext cx="457200" cy="1024128"/>
+          </a:xfrm>
+          <a:prstGeom prst="line">
+            <a:avLst/>
+          </a:prstGeom>
+          <a:noFill/>
+          <a:ln w="25400">
+            <a:solidFill>
+              <a:srgbClr val="C4CFD6"/>
+            </a:solidFill>
+            <a:prstDash val="solid"/>
+            <a:tailEnd type="triangle"/>
+          </a:ln>
+        </p:spPr>
+      </p:sp>
+      <p:sp>
+        <p:nvSpPr>
+          <p:cNvPr id="13" name="Text 11"/>
+          <p:cNvSpPr/>
+          <p:nvPr/>
+        </p:nvSpPr>
+        <p:spPr>
+          <a:xfrm>
+            <a:off x="1554480" y="2724912"/>
+            <a:ext cx="1426464" cy="768096"/>
+          </a:xfrm>
+          <a:prstGeom prst="roundRect">
+            <a:avLst>
+              <a:gd name="adj" fmla="val 9524"/>
+            </a:avLst>
+          </a:prstGeom>
+          <a:solidFill>
+            <a:srgbClr val="E8F6F0"/>
+          </a:solidFill>
+          <a:ln w="15875">
+            <a:solidFill>
+              <a:srgbClr val="02A878"/>
+            </a:solidFill>
+          </a:ln>
+        </p:spPr>
+        <p:txBody>
+          <a:bodyPr wrap="square" lIns="0" tIns="0" rIns="0" bIns="0" rtlCol="0" anchor="ctr"/>
+          <a:lstStyle/>
+          <a:p>
+            <a:pPr algn="ctr" indent="0" marL="0">
+              <a:lnSpc>
+                <a:spcPct val="105000"/>
+              </a:lnSpc>
+              <a:buNone/>
+            </a:pPr>
+            <a:r>
+              <a:rPr lang="en-US" sz="1150" b="1" dirty="0">
+                <a:solidFill>
+                  <a:srgbClr val="17313B"/>
+                </a:solidFill>
+                <a:latin typeface="Malgun Gothic" pitchFamily="34" charset="0"/>
+                <a:ea typeface="Malgun Gothic" pitchFamily="34" charset="-122"/>
+                <a:cs typeface="Malgun Gothic" pitchFamily="34" charset="-120"/>
+              </a:rPr>
+              <a:t>고객 락인</a:t>
+            </a:r>
+            <a:endParaRPr lang="en-US" sz="1150" dirty="0"/>
+          </a:p>
+          <a:p>
+            <a:pPr algn="ctr" indent="0" marL="0">
+              <a:lnSpc>
+                <a:spcPct val="105000"/>
+              </a:lnSpc>
+              <a:buNone/>
+            </a:pPr>
+            <a:r>
+              <a:rPr lang="en-US" sz="1150" b="1" dirty="0">
+                <a:solidFill>
+                  <a:srgbClr val="17313B"/>
+                </a:solidFill>
+                <a:latin typeface="Malgun Gothic" pitchFamily="34" charset="0"/>
+                <a:ea typeface="Malgun Gothic" pitchFamily="34" charset="-122"/>
+                <a:cs typeface="Malgun Gothic" pitchFamily="34" charset="-120"/>
+              </a:rPr>
+              <a:t>다운턴 방어</a:t>
+            </a:r>
+            <a:endParaRPr lang="en-US" sz="1150" dirty="0"/>
+          </a:p>
+        </p:txBody>
+      </p:sp>
+      <p:sp>
+        <p:nvSpPr>
+          <p:cNvPr id="14" name="Text 12"/>
+          <p:cNvSpPr/>
+          <p:nvPr/>
+        </p:nvSpPr>
+        <p:spPr>
+          <a:xfrm>
+            <a:off x="457200" y="4754880"/>
+            <a:ext cx="3785616" cy="1371600"/>
+          </a:xfrm>
+          <a:prstGeom prst="roundRect">
+            <a:avLst>
+              <a:gd name="adj" fmla="val 5333"/>
+            </a:avLst>
+          </a:prstGeom>
+          <a:solidFill>
+            <a:srgbClr val="F5F7F8"/>
+          </a:solidFill>
+          <a:ln/>
+        </p:spPr>
+        <p:txBody>
+          <a:bodyPr wrap="square" lIns="1524" tIns="1524" rIns="1524" bIns="1524" rtlCol="0" anchor="ctr"/>
+          <a:lstStyle/>
+          <a:p>
+            <a:pPr algn="l" indent="0" marL="0">
+              <a:lnSpc>
+                <a:spcPct val="115000"/>
+              </a:lnSpc>
+              <a:buNone/>
+            </a:pPr>
+            <a:r>
+              <a:rPr lang="en-US" sz="1250" b="1" dirty="0">
+                <a:solidFill>
+                  <a:srgbClr val="17313B"/>
+                </a:solidFill>
+                <a:latin typeface="Malgun Gothic" pitchFamily="34" charset="0"/>
+                <a:ea typeface="Malgun Gothic" pitchFamily="34" charset="-122"/>
+                <a:cs typeface="Malgun Gothic" pitchFamily="34" charset="-120"/>
+              </a:rPr>
+              <a:t>락인 플라이휠</a:t>
+            </a:r>
+            <a:endParaRPr lang="en-US" sz="1250" dirty="0"/>
+          </a:p>
+          <a:p>
+            <a:pPr algn="l" indent="0" marL="0">
+              <a:lnSpc>
+                <a:spcPct val="115000"/>
+              </a:lnSpc>
+              <a:buNone/>
+            </a:pPr>
+            <a:r>
+              <a:rPr lang="en-US" sz="1050" dirty="0">
+                <a:solidFill>
+                  <a:srgbClr val="5A7184"/>
+                </a:solidFill>
+                <a:latin typeface="Malgun Gothic" pitchFamily="34" charset="0"/>
+                <a:ea typeface="Malgun Gothic" pitchFamily="34" charset="-122"/>
+                <a:cs typeface="Malgun Gothic" pitchFamily="34" charset="-120"/>
+              </a:rPr>
+              <a:t>워크로드 유입 → 최적화 심화 → 전환비용 증가. 계약이 끝나도 갈아타기 어려운 관계가 다운턴의 방어벽이 된다</a:t>
+            </a:r>
+            <a:endParaRPr lang="en-US" sz="1250" dirty="0"/>
+          </a:p>
+        </p:txBody>
+      </p:sp>
+      <p:sp>
+        <p:nvSpPr>
+          <p:cNvPr id="15" name="Shape 13"/>
+          <p:cNvSpPr/>
+          <p:nvPr/>
+        </p:nvSpPr>
+        <p:spPr>
+          <a:xfrm>
+            <a:off x="4434840" y="1207008"/>
+            <a:ext cx="7296912" cy="1645920"/>
+          </a:xfrm>
+          <a:prstGeom prst="roundRect">
+            <a:avLst>
+              <a:gd name="adj" fmla="val 5000"/>
+            </a:avLst>
+          </a:prstGeom>
+          <a:solidFill>
+            <a:srgbClr val="F5F7F8"/>
+          </a:solidFill>
+          <a:ln/>
+        </p:spPr>
+      </p:sp>
+      <p:sp>
+        <p:nvSpPr>
+          <p:cNvPr id="16" name="Text 14"/>
+          <p:cNvSpPr/>
+          <p:nvPr/>
+        </p:nvSpPr>
+        <p:spPr>
+          <a:xfrm>
+            <a:off x="4599432" y="1353312"/>
+            <a:ext cx="329184" cy="329184"/>
+          </a:xfrm>
+          <a:prstGeom prst="ellipse">
+            <a:avLst/>
+          </a:prstGeom>
+          <a:solidFill>
+            <a:srgbClr val="17313B"/>
+          </a:solidFill>
+          <a:ln/>
+        </p:spPr>
+        <p:txBody>
+          <a:bodyPr wrap="square" lIns="0" tIns="0" rIns="0" bIns="0" rtlCol="0" anchor="ctr"/>
+          <a:lstStyle/>
+          <a:p>
+            <a:pPr algn="ctr" indent="0" marL="0">
+              <a:buNone/>
+            </a:pPr>
+            <a:r>
+              <a:rPr lang="en-US" sz="1500" b="1" dirty="0">
+                <a:solidFill>
+                  <a:srgbClr val="FFFFFF"/>
+                </a:solidFill>
+                <a:latin typeface="Malgun Gothic" pitchFamily="34" charset="0"/>
+                <a:ea typeface="Malgun Gothic" pitchFamily="34" charset="-122"/>
+                <a:cs typeface="Malgun Gothic" pitchFamily="34" charset="-120"/>
+              </a:rPr>
+              <a:t>1</a:t>
+            </a:r>
+            <a:endParaRPr lang="en-US" sz="1500" dirty="0"/>
+          </a:p>
+        </p:txBody>
+      </p:sp>
+      <p:sp>
+        <p:nvSpPr>
+          <p:cNvPr id="17" name="Shape 15"/>
+          <p:cNvSpPr/>
+          <p:nvPr/>
+        </p:nvSpPr>
+        <p:spPr>
+          <a:xfrm>
+            <a:off x="5020056" y="1325880"/>
+            <a:ext cx="384048" cy="384048"/>
+          </a:xfrm>
+          <a:prstGeom prst="ellipse">
+            <a:avLst/>
+          </a:prstGeom>
+          <a:solidFill>
+            <a:srgbClr val="028090"/>
+          </a:solidFill>
+          <a:ln/>
+        </p:spPr>
+      </p:sp>
+      <p:pic>
+        <p:nvPicPr>
+          <p:cNvPr id="18" name="Image 0" descr="preencoded.png">    </p:cNvPr>
+          <p:cNvPicPr>
+            <a:picLocks noChangeAspect="1"/>
+          </p:cNvPicPr>
+          <p:nvPr/>
+        </p:nvPicPr>
+        <p:blipFill>
+          <a:blip r:embed="rId1"/>
+          <a:stretch>
+            <a:fillRect/>
+          </a:stretch>
+        </p:blipFill>
+        <p:spPr>
+          <a:xfrm>
+            <a:off x="5112228" y="1418052"/>
+            <a:ext cx="199705" cy="199705"/>
+          </a:xfrm>
+          <a:prstGeom prst="rect">
+            <a:avLst/>
+          </a:prstGeom>
+        </p:spPr>
+      </p:pic>
+      <p:sp>
+        <p:nvSpPr>
+          <p:cNvPr id="19" name="Text 16"/>
+          <p:cNvSpPr/>
+          <p:nvPr/>
+        </p:nvSpPr>
+        <p:spPr>
+          <a:xfrm>
+            <a:off x="5532120" y="1335024"/>
+            <a:ext cx="6035040" cy="365760"/>
+          </a:xfrm>
+          <a:prstGeom prst="rect">
+            <a:avLst/>
+          </a:prstGeom>
+          <a:noFill/>
+          <a:ln/>
+        </p:spPr>
+        <p:txBody>
+          <a:bodyPr wrap="square" lIns="0" tIns="0" rIns="0" bIns="0" rtlCol="0" anchor="ctr"/>
+          <a:lstStyle/>
+          <a:p>
+            <a:pPr indent="0" marL="0">
+              <a:buNone/>
+            </a:pPr>
+            <a:r>
+              <a:rPr lang="en-US" sz="1400" b="1" dirty="0">
+                <a:solidFill>
+                  <a:srgbClr val="17313B"/>
+                </a:solidFill>
+                <a:latin typeface="Malgun Gothic" pitchFamily="34" charset="0"/>
+                <a:ea typeface="Malgun Gothic" pitchFamily="34" charset="-122"/>
+                <a:cs typeface="Malgun Gothic" pitchFamily="34" charset="-120"/>
+              </a:rPr>
+              <a:t>협상력의 창이 열려 있을 때 워크로드 교환을 제안한다</a:t>
+            </a:r>
+            <a:endParaRPr lang="en-US" sz="1400" dirty="0"/>
+          </a:p>
+        </p:txBody>
+      </p:sp>
+      <p:sp>
+        <p:nvSpPr>
+          <p:cNvPr id="20" name="Text 17"/>
+          <p:cNvSpPr/>
+          <p:nvPr/>
+        </p:nvSpPr>
+        <p:spPr>
+          <a:xfrm>
+            <a:off x="4645152" y="1755648"/>
+            <a:ext cx="6903720" cy="1024128"/>
+          </a:xfrm>
+          <a:prstGeom prst="rect">
+            <a:avLst/>
+          </a:prstGeom>
+          <a:noFill/>
+          <a:ln/>
+        </p:spPr>
+        <p:txBody>
+          <a:bodyPr wrap="square" lIns="0" tIns="0" rIns="0" bIns="0" rtlCol="0" anchor="t"/>
+          <a:lstStyle/>
+          <a:p>
+            <a:pPr marL="342900" indent="-342900">
+              <a:lnSpc>
+                <a:spcPct val="108000"/>
+              </a:lnSpc>
+              <a:spcAft>
+                <a:spcPts val="400"/>
+              </a:spcAft>
+              <a:buSzPct val="100000"/>
+              <a:buChar char="•"/>
+            </a:pPr>
+            <a:r>
+              <a:rPr lang="en-US" sz="1050" dirty="0">
+                <a:solidFill>
+                  <a:srgbClr val="17313B"/>
+                </a:solidFill>
+                <a:latin typeface="Malgun Gothic" pitchFamily="34" charset="0"/>
+                <a:ea typeface="Malgun Gothic" pitchFamily="34" charset="-122"/>
+                <a:cs typeface="Malgun Gothic" pitchFamily="34" charset="-120"/>
+              </a:rPr>
+              <a:t>대상: 하이퍼스케일러 + 스토리지 박스 업체(Pure Storage·VAST Data·DDN)</a:t>
+            </a:r>
+            <a:endParaRPr lang="en-US" sz="1050" dirty="0"/>
+          </a:p>
+          <a:p>
+            <a:pPr marL="342900" indent="-342900">
+              <a:lnSpc>
+                <a:spcPct val="108000"/>
+              </a:lnSpc>
+              <a:spcAft>
+                <a:spcPts val="400"/>
+              </a:spcAft>
+              <a:buSzPct val="100000"/>
+              <a:buChar char="•"/>
+            </a:pPr>
+            <a:r>
+              <a:rPr lang="en-US" sz="1050" dirty="0">
+                <a:solidFill>
+                  <a:srgbClr val="17313B"/>
+                </a:solidFill>
+                <a:latin typeface="Malgun Gothic" pitchFamily="34" charset="0"/>
+                <a:ea typeface="Malgun Gothic" pitchFamily="34" charset="-122"/>
+                <a:cs typeface="Malgun Gothic" pitchFamily="34" charset="-120"/>
+              </a:rPr>
+              <a:t>딜 구조: 고객 워크로드 공유 ↔ 그 워크로드에 최적화한 FDP SSD 공급</a:t>
+            </a:r>
+            <a:endParaRPr lang="en-US" sz="1050" dirty="0"/>
+          </a:p>
+          <a:p>
+            <a:pPr marL="342900" indent="-342900">
+              <a:lnSpc>
+                <a:spcPct val="108000"/>
+              </a:lnSpc>
+              <a:spcAft>
+                <a:spcPts val="400"/>
+              </a:spcAft>
+              <a:buSzPct val="100000"/>
+              <a:buChar char="•"/>
+            </a:pPr>
+            <a:r>
+              <a:rPr lang="en-US" sz="1050" dirty="0">
+                <a:solidFill>
+                  <a:srgbClr val="17313B"/>
+                </a:solidFill>
+                <a:latin typeface="Malgun Gothic" pitchFamily="34" charset="0"/>
+                <a:ea typeface="Malgun Gothic" pitchFamily="34" charset="-122"/>
+                <a:cs typeface="Malgun Gothic" pitchFamily="34" charset="-120"/>
+              </a:rPr>
+              <a:t>고객 효익: 성능·수명 개선과 TCO 절감으로 거절하기 어려운 제안 (공급부족 국면 한정의 창)</a:t>
+            </a:r>
+            <a:endParaRPr lang="en-US" sz="1050" dirty="0"/>
+          </a:p>
+        </p:txBody>
+      </p:sp>
+      <p:sp>
+        <p:nvSpPr>
+          <p:cNvPr id="21" name="Shape 18"/>
+          <p:cNvSpPr/>
+          <p:nvPr/>
+        </p:nvSpPr>
+        <p:spPr>
+          <a:xfrm>
+            <a:off x="4434840" y="2980944"/>
+            <a:ext cx="7296912" cy="1645920"/>
+          </a:xfrm>
+          <a:prstGeom prst="roundRect">
+            <a:avLst>
+              <a:gd name="adj" fmla="val 5000"/>
+            </a:avLst>
+          </a:prstGeom>
+          <a:solidFill>
+            <a:srgbClr val="F5F7F8"/>
+          </a:solidFill>
+          <a:ln/>
+        </p:spPr>
+      </p:sp>
+      <p:sp>
+        <p:nvSpPr>
+          <p:cNvPr id="22" name="Text 19"/>
+          <p:cNvSpPr/>
+          <p:nvPr/>
+        </p:nvSpPr>
+        <p:spPr>
+          <a:xfrm>
+            <a:off x="4599432" y="3127248"/>
+            <a:ext cx="329184" cy="329184"/>
+          </a:xfrm>
+          <a:prstGeom prst="ellipse">
+            <a:avLst/>
+          </a:prstGeom>
+          <a:solidFill>
+            <a:srgbClr val="17313B"/>
+          </a:solidFill>
+          <a:ln/>
+        </p:spPr>
+        <p:txBody>
+          <a:bodyPr wrap="square" lIns="0" tIns="0" rIns="0" bIns="0" rtlCol="0" anchor="ctr"/>
+          <a:lstStyle/>
+          <a:p>
+            <a:pPr algn="ctr" indent="0" marL="0">
+              <a:buNone/>
+            </a:pPr>
+            <a:r>
+              <a:rPr lang="en-US" sz="1500" b="1" dirty="0">
+                <a:solidFill>
+                  <a:srgbClr val="FFFFFF"/>
+                </a:solidFill>
+                <a:latin typeface="Malgun Gothic" pitchFamily="34" charset="0"/>
+                <a:ea typeface="Malgun Gothic" pitchFamily="34" charset="-122"/>
+                <a:cs typeface="Malgun Gothic" pitchFamily="34" charset="-120"/>
+              </a:rPr>
+              <a:t>2</a:t>
+            </a:r>
+            <a:endParaRPr lang="en-US" sz="1500" dirty="0"/>
+          </a:p>
+        </p:txBody>
+      </p:sp>
+      <p:sp>
+        <p:nvSpPr>
+          <p:cNvPr id="23" name="Shape 20"/>
+          <p:cNvSpPr/>
+          <p:nvPr/>
+        </p:nvSpPr>
+        <p:spPr>
+          <a:xfrm>
+            <a:off x="5020056" y="3099816"/>
+            <a:ext cx="384048" cy="384048"/>
+          </a:xfrm>
+          <a:prstGeom prst="ellipse">
+            <a:avLst/>
+          </a:prstGeom>
+          <a:solidFill>
+            <a:srgbClr val="4C7C94"/>
+          </a:solidFill>
+          <a:ln/>
+        </p:spPr>
+      </p:sp>
+      <p:pic>
+        <p:nvPicPr>
+          <p:cNvPr id="24" name="Image 1" descr="preencoded.png">    </p:cNvPr>
+          <p:cNvPicPr>
+            <a:picLocks noChangeAspect="1"/>
+          </p:cNvPicPr>
+          <p:nvPr/>
+        </p:nvPicPr>
+        <p:blipFill>
+          <a:blip r:embed="rId2"/>
+          <a:stretch>
+            <a:fillRect/>
+          </a:stretch>
+        </p:blipFill>
+        <p:spPr>
+          <a:xfrm>
+            <a:off x="5112228" y="3191988"/>
+            <a:ext cx="199705" cy="199705"/>
+          </a:xfrm>
+          <a:prstGeom prst="rect">
+            <a:avLst/>
+          </a:prstGeom>
+        </p:spPr>
+      </p:pic>
+      <p:sp>
+        <p:nvSpPr>
+          <p:cNvPr id="25" name="Text 21"/>
+          <p:cNvSpPr/>
+          <p:nvPr/>
+        </p:nvSpPr>
+        <p:spPr>
+          <a:xfrm>
+            <a:off x="5532120" y="3108960"/>
+            <a:ext cx="6035040" cy="365760"/>
+          </a:xfrm>
+          <a:prstGeom prst="rect">
+            <a:avLst/>
+          </a:prstGeom>
+          <a:noFill/>
+          <a:ln/>
+        </p:spPr>
+        <p:txBody>
+          <a:bodyPr wrap="square" lIns="0" tIns="0" rIns="0" bIns="0" rtlCol="0" anchor="ctr"/>
+          <a:lstStyle/>
+          <a:p>
+            <a:pPr indent="0" marL="0">
+              <a:buNone/>
+            </a:pPr>
+            <a:r>
+              <a:rPr lang="en-US" sz="1400" b="1" dirty="0">
+                <a:solidFill>
+                  <a:srgbClr val="17313B"/>
+                </a:solidFill>
+                <a:latin typeface="Malgun Gothic" pitchFamily="34" charset="0"/>
+                <a:ea typeface="Malgun Gothic" pitchFamily="34" charset="-122"/>
+                <a:cs typeface="Malgun Gothic" pitchFamily="34" charset="-120"/>
+              </a:rPr>
+              <a:t>호스트를 이해하는 최적화 개발 역량을 채용·양성으로 확보한다</a:t>
+            </a:r>
+            <a:endParaRPr lang="en-US" sz="1400" dirty="0"/>
+          </a:p>
+        </p:txBody>
+      </p:sp>
+      <p:sp>
+        <p:nvSpPr>
+          <p:cNvPr id="26" name="Text 22"/>
+          <p:cNvSpPr/>
+          <p:nvPr/>
+        </p:nvSpPr>
+        <p:spPr>
+          <a:xfrm>
+            <a:off x="4645152" y="3529584"/>
+            <a:ext cx="6903720" cy="1024128"/>
+          </a:xfrm>
+          <a:prstGeom prst="rect">
+            <a:avLst/>
+          </a:prstGeom>
+          <a:noFill/>
+          <a:ln/>
+        </p:spPr>
+        <p:txBody>
+          <a:bodyPr wrap="square" lIns="0" tIns="0" rIns="0" bIns="0" rtlCol="0" anchor="t"/>
+          <a:lstStyle/>
+          <a:p>
+            <a:pPr marL="342900" indent="-342900">
+              <a:lnSpc>
+                <a:spcPct val="108000"/>
+              </a:lnSpc>
+              <a:spcAft>
+                <a:spcPts val="400"/>
+              </a:spcAft>
+              <a:buSzPct val="100000"/>
+              <a:buChar char="•"/>
+            </a:pPr>
+            <a:r>
+              <a:rPr lang="en-US" sz="1050" dirty="0">
+                <a:solidFill>
+                  <a:srgbClr val="17313B"/>
+                </a:solidFill>
+                <a:latin typeface="Malgun Gothic" pitchFamily="34" charset="0"/>
+                <a:ea typeface="Malgun Gothic" pitchFamily="34" charset="-122"/>
+                <a:cs typeface="Malgun Gothic" pitchFamily="34" charset="-120"/>
+              </a:rPr>
+              <a:t>전문가 5종: ① 커널 블록계층·io_uring·NVMe ② SPDK 유저스페이스 ③ DB·캐시 내부(RocksDB·CacheLib·Ceph) ④ 성능·워크로드 분석(fio·eBPF·WAF) ⑤ FTL·미디어 모델(사내 강점 브리지)</a:t>
+            </a:r>
+            <a:endParaRPr lang="en-US" sz="1050" dirty="0"/>
+          </a:p>
+          <a:p>
+            <a:pPr marL="342900" indent="-342900">
+              <a:lnSpc>
+                <a:spcPct val="108000"/>
+              </a:lnSpc>
+              <a:spcAft>
+                <a:spcPts val="400"/>
+              </a:spcAft>
+              <a:buSzPct val="100000"/>
+              <a:buChar char="•"/>
+            </a:pPr>
+            <a:r>
+              <a:rPr lang="en-US" sz="1050" dirty="0">
+                <a:solidFill>
+                  <a:srgbClr val="17313B"/>
+                </a:solidFill>
+                <a:latin typeface="Malgun Gothic" pitchFamily="34" charset="0"/>
+                <a:ea typeface="Malgun Gothic" pitchFamily="34" charset="-122"/>
+                <a:cs typeface="Malgun Gothic" pitchFamily="34" charset="-120"/>
+              </a:rPr>
+              <a:t>확보: 오픈소스 커미터·하이퍼스케일러 스토리지팀 출신 채용 + 사내 FW 인력의 호스트 SW 전환 트랙(오픈소스 기여를 평가에 반영)</a:t>
+            </a:r>
+            <a:endParaRPr lang="en-US" sz="1050" dirty="0"/>
+          </a:p>
+        </p:txBody>
+      </p:sp>
+      <p:sp>
+        <p:nvSpPr>
+          <p:cNvPr id="27" name="Shape 23"/>
+          <p:cNvSpPr/>
+          <p:nvPr/>
+        </p:nvSpPr>
+        <p:spPr>
+          <a:xfrm>
+            <a:off x="4434840" y="4754880"/>
+            <a:ext cx="7296912" cy="1645920"/>
+          </a:xfrm>
+          <a:prstGeom prst="roundRect">
+            <a:avLst>
+              <a:gd name="adj" fmla="val 5000"/>
+            </a:avLst>
+          </a:prstGeom>
+          <a:solidFill>
+            <a:srgbClr val="F5F7F8"/>
+          </a:solidFill>
+          <a:ln/>
+        </p:spPr>
+      </p:sp>
+      <p:sp>
+        <p:nvSpPr>
+          <p:cNvPr id="28" name="Text 24"/>
+          <p:cNvSpPr/>
+          <p:nvPr/>
+        </p:nvSpPr>
+        <p:spPr>
+          <a:xfrm>
+            <a:off x="4599432" y="4901184"/>
+            <a:ext cx="329184" cy="329184"/>
+          </a:xfrm>
+          <a:prstGeom prst="ellipse">
+            <a:avLst/>
+          </a:prstGeom>
+          <a:solidFill>
+            <a:srgbClr val="17313B"/>
+          </a:solidFill>
+          <a:ln/>
+        </p:spPr>
+        <p:txBody>
+          <a:bodyPr wrap="square" lIns="0" tIns="0" rIns="0" bIns="0" rtlCol="0" anchor="ctr"/>
+          <a:lstStyle/>
+          <a:p>
+            <a:pPr algn="ctr" indent="0" marL="0">
+              <a:buNone/>
+            </a:pPr>
+            <a:r>
+              <a:rPr lang="en-US" sz="1500" b="1" dirty="0">
+                <a:solidFill>
+                  <a:srgbClr val="FFFFFF"/>
+                </a:solidFill>
+                <a:latin typeface="Malgun Gothic" pitchFamily="34" charset="0"/>
+                <a:ea typeface="Malgun Gothic" pitchFamily="34" charset="-122"/>
+                <a:cs typeface="Malgun Gothic" pitchFamily="34" charset="-120"/>
+              </a:rPr>
+              <a:t>3</a:t>
+            </a:r>
+            <a:endParaRPr lang="en-US" sz="1500" dirty="0"/>
+          </a:p>
+        </p:txBody>
+      </p:sp>
+      <p:sp>
+        <p:nvSpPr>
+          <p:cNvPr id="29" name="Shape 25"/>
+          <p:cNvSpPr/>
+          <p:nvPr/>
+        </p:nvSpPr>
+        <p:spPr>
+          <a:xfrm>
+            <a:off x="5020056" y="4873752"/>
+            <a:ext cx="384048" cy="384048"/>
+          </a:xfrm>
+          <a:prstGeom prst="ellipse">
+            <a:avLst/>
+          </a:prstGeom>
+          <a:solidFill>
+            <a:srgbClr val="02A878"/>
+          </a:solidFill>
+          <a:ln/>
+        </p:spPr>
+      </p:sp>
+      <p:pic>
+        <p:nvPicPr>
+          <p:cNvPr id="30" name="Image 2" descr="preencoded.png">    </p:cNvPr>
+          <p:cNvPicPr>
+            <a:picLocks noChangeAspect="1"/>
+          </p:cNvPicPr>
+          <p:nvPr/>
+        </p:nvPicPr>
+        <p:blipFill>
+          <a:blip r:embed="rId3"/>
+          <a:stretch>
+            <a:fillRect/>
+          </a:stretch>
+        </p:blipFill>
+        <p:spPr>
+          <a:xfrm>
+            <a:off x="5112228" y="4965924"/>
+            <a:ext cx="199705" cy="199705"/>
+          </a:xfrm>
+          <a:prstGeom prst="rect">
+            <a:avLst/>
+          </a:prstGeom>
+        </p:spPr>
+      </p:pic>
+      <p:sp>
+        <p:nvSpPr>
+          <p:cNvPr id="31" name="Text 26"/>
+          <p:cNvSpPr/>
+          <p:nvPr/>
+        </p:nvSpPr>
+        <p:spPr>
+          <a:xfrm>
+            <a:off x="5532120" y="4882896"/>
+            <a:ext cx="6035040" cy="365760"/>
+          </a:xfrm>
+          <a:prstGeom prst="rect">
+            <a:avLst/>
+          </a:prstGeom>
+          <a:noFill/>
+          <a:ln/>
+        </p:spPr>
+        <p:txBody>
+          <a:bodyPr wrap="square" lIns="0" tIns="0" rIns="0" bIns="0" rtlCol="0" anchor="ctr"/>
+          <a:lstStyle/>
+          <a:p>
+            <a:pPr indent="0" marL="0">
+              <a:buNone/>
+            </a:pPr>
+            <a:r>
+              <a:rPr lang="en-US" sz="1400" b="1" dirty="0">
+                <a:solidFill>
+                  <a:srgbClr val="17313B"/>
+                </a:solidFill>
+                <a:latin typeface="Malgun Gothic" pitchFamily="34" charset="0"/>
+                <a:ea typeface="Malgun Gothic" pitchFamily="34" charset="-122"/>
+                <a:cs typeface="Malgun Gothic" pitchFamily="34" charset="-120"/>
+              </a:rPr>
+              <a:t>FDE를 고객 옆에 두고 FDP 생태계에 함께 기여한다</a:t>
+            </a:r>
+            <a:endParaRPr lang="en-US" sz="1400" dirty="0"/>
+          </a:p>
+        </p:txBody>
+      </p:sp>
+      <p:sp>
+        <p:nvSpPr>
+          <p:cNvPr id="32" name="Text 27"/>
+          <p:cNvSpPr/>
+          <p:nvPr/>
+        </p:nvSpPr>
+        <p:spPr>
+          <a:xfrm>
+            <a:off x="4645152" y="5303520"/>
+            <a:ext cx="6903720" cy="1024128"/>
+          </a:xfrm>
+          <a:prstGeom prst="rect">
+            <a:avLst/>
+          </a:prstGeom>
+          <a:noFill/>
+          <a:ln/>
+        </p:spPr>
+        <p:txBody>
+          <a:bodyPr wrap="square" lIns="0" tIns="0" rIns="0" bIns="0" rtlCol="0" anchor="t"/>
+          <a:lstStyle/>
+          <a:p>
+            <a:pPr marL="342900" indent="-342900">
+              <a:lnSpc>
+                <a:spcPct val="108000"/>
+              </a:lnSpc>
+              <a:spcAft>
+                <a:spcPts val="400"/>
+              </a:spcAft>
+              <a:buSzPct val="100000"/>
+              <a:buChar char="•"/>
+            </a:pPr>
+            <a:r>
+              <a:rPr lang="en-US" sz="1050" dirty="0">
+                <a:solidFill>
+                  <a:srgbClr val="17313B"/>
+                </a:solidFill>
+                <a:latin typeface="Malgun Gothic" pitchFamily="34" charset="0"/>
+                <a:ea typeface="Malgun Gothic" pitchFamily="34" charset="-122"/>
+                <a:cs typeface="Malgun Gothic" pitchFamily="34" charset="-120"/>
+              </a:rPr>
+              <a:t>채용: 실리콘밸리 현지 중심, 오픈소스 스토리지 기여자 우대, 영어 커뮤니케이션 필수</a:t>
+            </a:r>
+            <a:endParaRPr lang="en-US" sz="1050" dirty="0"/>
+          </a:p>
+          <a:p>
+            <a:pPr marL="342900" indent="-342900">
+              <a:lnSpc>
+                <a:spcPct val="108000"/>
+              </a:lnSpc>
+              <a:spcAft>
+                <a:spcPts val="400"/>
+              </a:spcAft>
+              <a:buSzPct val="100000"/>
+              <a:buChar char="•"/>
+            </a:pPr>
+            <a:r>
+              <a:rPr lang="en-US" sz="1050" dirty="0">
+                <a:solidFill>
+                  <a:srgbClr val="17313B"/>
+                </a:solidFill>
+                <a:latin typeface="Malgun Gothic" pitchFamily="34" charset="0"/>
+                <a:ea typeface="Malgun Gothic" pitchFamily="34" charset="-122"/>
+                <a:cs typeface="Malgun Gothic" pitchFamily="34" charset="-120"/>
+              </a:rPr>
+              <a:t>양성: 본사 엔지니어 미국 로테이션(6~12개월) + 현지 FDE 멘토 페어링</a:t>
+            </a:r>
+            <a:endParaRPr lang="en-US" sz="1050" dirty="0"/>
+          </a:p>
+          <a:p>
+            <a:pPr marL="342900" indent="-342900">
+              <a:lnSpc>
+                <a:spcPct val="108000"/>
+              </a:lnSpc>
+              <a:spcAft>
+                <a:spcPts val="400"/>
+              </a:spcAft>
+              <a:buSzPct val="100000"/>
+              <a:buChar char="•"/>
+            </a:pPr>
+            <a:r>
+              <a:rPr lang="en-US" sz="1050" dirty="0">
+                <a:solidFill>
+                  <a:srgbClr val="17313B"/>
+                </a:solidFill>
+                <a:latin typeface="Malgun Gothic" pitchFamily="34" charset="0"/>
+                <a:ea typeface="Malgun Gothic" pitchFamily="34" charset="-122"/>
+                <a:cs typeface="Malgun Gothic" pitchFamily="34" charset="-120"/>
+              </a:rPr>
+              <a:t>운영: 파일럿 1~2사 상주(Pod 소속·dual-ladder), outcome 평가(FDP 활성화 용량), 커널·SPDK·CacheLib 업스트림 기여로 호명</a:t>
+            </a:r>
+            <a:endParaRPr lang="en-US" sz="1050" dirty="0"/>
           </a:p>
         </p:txBody>
       </p:sp>

</xml_diff>